<commit_message>
Add investor pitch deck and strip all emojis from all presentations
- New SageAI_Investor_Pitch.pptx (14 slides): cover, executive summary,
  problem (quantified cost table), solution, market opportunity ($68.4B TAM),
  product capabilities, five technology moats, business model (SaaS + services),
  competitive landscape, go-to-market (3 phases), traction (12 phases / 383 tests),
  3-year financial projections, the ask ($4.5M Series A), closing
- Stripped all emoji characters from Business Case and Tech Pitch — replaced
  with clean plain-text alternatives (numbers, dash prefixes, plain status words)
- Removed emoji prefixes from all bullet lists and table status columns
- DISCLAIMER constant updated to remove emoji prefix
- All three decks now fully corporate-safe for regulated industry audiences

Co-Authored-By: Claude Sonnet 4.6 <noreply@anthropic.com>
</commit_message>
<xml_diff>
--- a/docs/SageAI_Business_Case.pptx
+++ b/docs/SageAI_Business_Case.pptx
@@ -4303,7 +4303,7 @@
                             <a:srgbClr val="0D1B2A"/>
                           </a:solidFill>
                         </a:rPr>
-                        <a:t>Phases 0–4: Core</a:t>
+                        <a:t>Phases 0-4: Core</a:t>
                       </a:r>
                     </a:p>
                   </a:txBody>
@@ -4347,7 +4347,7 @@
                             <a:srgbClr val="0D1B2A"/>
                           </a:solidFill>
                         </a:rPr>
-                        <a:t>Agents · API · Web UI · Approval gate · Audit log</a:t>
+                        <a:t>Agents, API, Web UI, Approval gate, Audit log</a:t>
                       </a:r>
                     </a:p>
                   </a:txBody>
@@ -4369,7 +4369,7 @@
                             <a:srgbClr val="0D1B2A"/>
                           </a:solidFill>
                         </a:rPr>
-                        <a:t>✅ Complete</a:t>
+                        <a:t>Complete</a:t>
                       </a:r>
                     </a:p>
                   </a:txBody>
@@ -4459,7 +4459,7 @@
                             <a:srgbClr val="0D1B2A"/>
                           </a:solidFill>
                         </a:rPr>
-                        <a:t>✅ Complete</a:t>
+                        <a:t>Complete</a:t>
                       </a:r>
                     </a:p>
                   </a:txBody>
@@ -4527,7 +4527,7 @@
                             <a:srgbClr val="0D1B2A"/>
                           </a:solidFill>
                         </a:rPr>
-                        <a:t>Plain-language → YAML solution wizard</a:t>
+                        <a:t>Plain-language to YAML solution wizard</a:t>
                       </a:r>
                     </a:p>
                   </a:txBody>
@@ -4549,7 +4549,7 @@
                             <a:srgbClr val="0D1B2A"/>
                           </a:solidFill>
                         </a:rPr>
-                        <a:t>✅ Complete</a:t>
+                        <a:t>Complete</a:t>
                       </a:r>
                     </a:p>
                   </a:txBody>
@@ -4573,7 +4573,7 @@
                             <a:srgbClr val="0D1B2A"/>
                           </a:solidFill>
                         </a:rPr>
-                        <a:t>Phases 7–11</a:t>
+                        <a:t>Phases 7-11</a:t>
                       </a:r>
                     </a:p>
                   </a:txBody>
@@ -4617,7 +4617,7 @@
                             <a:srgbClr val="0D1B2A"/>
                           </a:solidFill>
                         </a:rPr>
-                        <a:t>Knowledge CRUD · Slack · Eval · Multi-tenant · Temporal</a:t>
+                        <a:t>Knowledge CRUD, Slack, Eval, Multi-tenant, Temporal</a:t>
                       </a:r>
                     </a:p>
                   </a:txBody>
@@ -4639,7 +4639,7 @@
                             <a:srgbClr val="0D1B2A"/>
                           </a:solidFill>
                         </a:rPr>
-                        <a:t>✅ Complete</a:t>
+                        <a:t>Complete</a:t>
                       </a:r>
                     </a:p>
                   </a:txBody>
@@ -4729,7 +4729,7 @@
                             <a:srgbClr val="0D1B2A"/>
                           </a:solidFill>
                         </a:rPr>
-                        <a:t>🔵 Next</a:t>
+                        <a:t>Next</a:t>
                       </a:r>
                     </a:p>
                   </a:txBody>
@@ -4797,7 +4797,7 @@
                             <a:srgbClr val="0D1B2A"/>
                           </a:solidFill>
                         </a:rPr>
-                        <a:t>KPI tracking · RAG feedback loop · first improvements</a:t>
+                        <a:t>KPI tracking, RAG feedback loop, first improvements</a:t>
                       </a:r>
                     </a:p>
                   </a:txBody>
@@ -4819,7 +4819,7 @@
                             <a:srgbClr val="0D1B2A"/>
                           </a:solidFill>
                         </a:rPr>
-                        <a:t>🔵 Planned</a:t>
+                        <a:t>Planned</a:t>
                       </a:r>
                     </a:p>
                   </a:txBody>
@@ -4887,7 +4887,7 @@
                             <a:srgbClr val="0D1B2A"/>
                           </a:solidFill>
                         </a:rPr>
-                        <a:t>Multi-team rollout · Spira integration · exec dashboards</a:t>
+                        <a:t>Multi-team rollout, Spira integration, exec dashboards</a:t>
                       </a:r>
                     </a:p>
                   </a:txBody>
@@ -4909,7 +4909,7 @@
                             <a:srgbClr val="0D1B2A"/>
                           </a:solidFill>
                         </a:rPr>
-                        <a:t>🔵 Planned</a:t>
+                        <a:t>Planned</a:t>
                       </a:r>
                     </a:p>
                   </a:txBody>
@@ -5201,7 +5201,7 @@
                   <a:srgbClr val="0D1B2A"/>
                 </a:solidFill>
               </a:rPr>
-              <a:t>✅  Production deployment approval (internal network)</a:t>
+              <a:t>Production deployment approval (internal network)</a:t>
             </a:r>
           </a:p>
         </p:txBody>
@@ -5235,7 +5235,7 @@
                   <a:srgbClr val="0D1B2A"/>
                 </a:solidFill>
               </a:rPr>
-              <a:t>✅  2-day engineering team training session</a:t>
+              <a:t>2-day engineering team training session</a:t>
             </a:r>
           </a:p>
         </p:txBody>
@@ -5269,7 +5269,7 @@
                   <a:srgbClr val="0D1B2A"/>
                 </a:solidFill>
               </a:rPr>
-              <a:t>✅  Access to GitLab, Metabase, Teams API credentials</a:t>
+              <a:t>Access to GitLab, Metabase, Teams API credentials</a:t>
             </a:r>
           </a:p>
         </p:txBody>
@@ -5303,7 +5303,7 @@
                   <a:srgbClr val="0D1B2A"/>
                 </a:solidFill>
               </a:rPr>
-              <a:t>✅  Dedicated server or VM  (8-core CPU · 32 GB RAM · optional GPU)</a:t>
+              <a:t>Dedicated server or VM  (8-core CPU · 32 GB RAM · optional GPU)</a:t>
             </a:r>
           </a:p>
         </p:txBody>
@@ -5371,7 +5371,7 @@
                   <a:srgbClr val="0D1B2A"/>
                 </a:solidFill>
               </a:rPr>
-              <a:t>📈  KPI dashboard by Week 2</a:t>
+              <a:t>KPI dashboard operational by Week 2</a:t>
             </a:r>
           </a:p>
         </p:txBody>
@@ -5405,7 +5405,7 @@
                   <a:srgbClr val="0D1B2A"/>
                 </a:solidFill>
               </a:rPr>
-              <a:t>⏱   60+ hours/week reclaimed from manual work</a:t>
+              <a:t>60+ hours/week reclaimed from manual work</a:t>
             </a:r>
           </a:p>
         </p:txBody>
@@ -5439,7 +5439,7 @@
                   <a:srgbClr val="0D1B2A"/>
                 </a:solidFill>
               </a:rPr>
-              <a:t>📋  ISO 13485 audit trail from day 1</a:t>
+              <a:t>ISO 13485 audit trail from day 1</a:t>
             </a:r>
           </a:p>
         </p:txBody>
@@ -5473,7 +5473,7 @@
                   <a:srgbClr val="0D1B2A"/>
                 </a:solidFill>
               </a:rPr>
-              <a:t>🤖  AI that learns from your engineers' expertise</a:t>
+              <a:t>AI that learns from your engineers' expertise</a:t>
             </a:r>
           </a:p>
         </p:txBody>
@@ -5507,7 +5507,7 @@
                   <a:srgbClr val="0D1B2A"/>
                 </a:solidFill>
               </a:rPr>
-              <a:t>💰  ROI positive within 2 months*</a:t>
+              <a:t>ROI positive within 2 months*</a:t>
             </a:r>
           </a:p>
         </p:txBody>
@@ -5704,7 +5704,7 @@
                   <a:srgbClr val="7B4F00"/>
                 </a:solidFill>
               </a:rPr>
-              <a:t>⚠️  COST DISCLAIMER — All financial figures, FTE savings, and ROI estimates on this slide are based on internal assumptions and industry benchmarks. They must be validated and replaced with actual measured data before any business decision is made.</a:t>
+              <a:t>IMPORTANT: All financial figures, FTE savings, and ROI estimates on this slide are based on internal assumptions and industry benchmarks. They must be validated and replaced with actual measured data before any business decision is made.</a:t>
             </a:r>
           </a:p>
         </p:txBody>
@@ -6083,7 +6083,7 @@
                   <a:srgbClr val="0D1B2A"/>
                 </a:solidFill>
               </a:rPr>
-              <a:t>⏱  45–60 min per error log analysis (manual triage)</a:t>
+              <a:t>45-60 min per error log analysis — manual triage every time</a:t>
             </a:r>
           </a:p>
         </p:txBody>
@@ -6117,7 +6117,7 @@
                   <a:srgbClr val="0D1B2A"/>
                 </a:solidFill>
               </a:rPr>
-              <a:t>🔁  3–5 day MR review backlog — engineers blocked waiting</a:t>
+              <a:t>3-5 day MR review backlog — engineers blocked waiting for feedback</a:t>
             </a:r>
           </a:p>
         </p:txBody>
@@ -6151,7 +6151,7 @@
                   <a:srgbClr val="0D1B2A"/>
                 </a:solidFill>
               </a:rPr>
-              <a:t>📋  8+ hours/week compliance reporting — pure administrative overhead</a:t>
+              <a:t>8+ hours/week compliance reporting — pure administrative overhead</a:t>
             </a:r>
           </a:p>
         </p:txBody>
@@ -6185,7 +6185,7 @@
                   <a:srgbClr val="0D1B2A"/>
                 </a:solidFill>
               </a:rPr>
-              <a:t>🧠  Expert knowledge lost permanently when engineers leave</a:t>
+              <a:t>Expert knowledge lost permanently when engineers leave the team</a:t>
             </a:r>
           </a:p>
         </p:txBody>
@@ -6219,7 +6219,7 @@
                   <a:srgbClr val="0D1B2A"/>
                 </a:solidFill>
               </a:rPr>
-              <a:t>⚠️   Error detection relies on human vigilance 24 / 7 — unsustainable</a:t>
+              <a:t>Error detection relies on human vigilance 24/7 — unsustainable at scale</a:t>
             </a:r>
           </a:p>
         </p:txBody>
@@ -6287,7 +6287,7 @@
                   <a:srgbClr val="0D1B2A"/>
                 </a:solidFill>
               </a:rPr>
-              <a:t>▶  Result: ~68 hrs/week of preventable manual work — every single week</a:t>
+              <a:t>Result: ~68 hrs/week of preventable manual work — every single week</a:t>
             </a:r>
           </a:p>
         </p:txBody>
@@ -6535,7 +6535,7 @@
                   <a:srgbClr val="0D1B2A"/>
                 </a:solidFill>
               </a:rPr>
-              <a:t>✅  Analyzes error logs in &lt; 60 seconds  (vs 45–60 min manual)</a:t>
+              <a:t>Analyzes error logs in under 60 seconds  (vs 45-60 min manual)</a:t>
             </a:r>
           </a:p>
         </p:txBody>
@@ -6569,7 +6569,7 @@
                   <a:srgbClr val="0D1B2A"/>
                 </a:solidFill>
               </a:rPr>
-              <a:t>✅  AI code reviews with multi-step ReAct reasoning loop</a:t>
+              <a:t>AI code reviews with multi-step ReAct reasoning loop</a:t>
             </a:r>
           </a:p>
         </p:txBody>
@@ -6603,7 +6603,7 @@
                   <a:srgbClr val="0D1B2A"/>
                 </a:solidFill>
               </a:rPr>
-              <a:t>✅  Monitors Teams, Metabase, GitLab — real-time event detection</a:t>
+              <a:t>Monitors Teams, Metabase, GitLab — real-time event detection</a:t>
             </a:r>
           </a:p>
         </p:txBody>
@@ -6637,7 +6637,7 @@
                   <a:srgbClr val="0D1B2A"/>
                 </a:solidFill>
               </a:rPr>
-              <a:t>✅  Every decision logged to immutable ISO 13485 audit trail</a:t>
+              <a:t>Every decision logged to immutable ISO 13485 audit trail</a:t>
             </a:r>
           </a:p>
         </p:txBody>
@@ -6671,7 +6671,7 @@
                   <a:srgbClr val="0D1B2A"/>
                 </a:solidFill>
               </a:rPr>
-              <a:t>✅  Human-in-the-loop: AI advises, humans decide — always</a:t>
+              <a:t>Human-in-the-loop: AI advises, humans decide — always</a:t>
             </a:r>
           </a:p>
         </p:txBody>
@@ -6705,7 +6705,7 @@
                   <a:srgbClr val="0D1B2A"/>
                 </a:solidFill>
               </a:rPr>
-              <a:t>✅  Learns from every correction via vector memory (RAG)</a:t>
+              <a:t>Learns from every correction via vector memory (RAG)</a:t>
             </a:r>
           </a:p>
         </p:txBody>
@@ -6739,7 +6739,7 @@
                   <a:srgbClr val="0D1B2A"/>
                 </a:solidFill>
               </a:rPr>
-              <a:t>✅  Web dashboard for all stakeholders — zero CLI required</a:t>
+              <a:t>Web dashboard for all stakeholders — zero CLI required</a:t>
             </a:r>
           </a:p>
         </p:txBody>
@@ -9158,7 +9158,7 @@
                   <a:srgbClr val="7B4F00"/>
                 </a:solidFill>
               </a:rPr>
-              <a:t>⚠️  COST DISCLAIMER — All financial figures, FTE savings, and ROI estimates on this slide are based on internal assumptions and industry benchmarks. They must be validated and replaced with actual measured data before any business decision is made.</a:t>
+              <a:t>IMPORTANT: All financial figures, FTE savings, and ROI estimates on this slide are based on internal assumptions and industry benchmarks. They must be validated and replaced with actual measured data before any business decision is made.</a:t>
             </a:r>
           </a:p>
         </p:txBody>
@@ -9967,7 +9967,7 @@
                   <a:srgbClr val="0078D4"/>
                 </a:solidFill>
               </a:rPr>
-              <a:t>▸  Event Sources</a:t>
+              <a:t>Event Sources</a:t>
             </a:r>
           </a:p>
         </p:txBody>
@@ -10035,7 +10035,7 @@
                   <a:srgbClr val="0078D4"/>
                 </a:solidFill>
               </a:rPr>
-              <a:t>▸  AI Agents</a:t>
+              <a:t>AI Agents</a:t>
             </a:r>
           </a:p>
         </p:txBody>
@@ -10103,7 +10103,7 @@
                   <a:srgbClr val="0078D4"/>
                 </a:solidFill>
               </a:rPr>
-              <a:t>▸  Compliance Layer</a:t>
+              <a:t>Compliance Layer</a:t>
             </a:r>
           </a:p>
         </p:txBody>
@@ -10392,7 +10392,7 @@
                             <a:srgbClr val="FFFFFF"/>
                           </a:solidFill>
                         </a:rPr>
-                        <a:t>#</a:t>
+                        <a:t>No.</a:t>
                       </a:r>
                     </a:p>
                   </a:txBody>
@@ -10460,7 +10460,7 @@
                             <a:srgbClr val="0D1B2A"/>
                           </a:solidFill>
                         </a:rPr>
-                        <a:t>🔍</a:t>
+                        <a:t>01</a:t>
                       </a:r>
                     </a:p>
                   </a:txBody>
@@ -10504,7 +10504,7 @@
                             <a:srgbClr val="0D1B2A"/>
                           </a:solidFill>
                         </a:rPr>
-                        <a:t>AI triage in &lt; 60 s — severity RED / AMBER / GREEN with root-cause reasoning</a:t>
+                        <a:t>AI triage in under 60 s — severity RED / AMBER / GREEN with root-cause reasoning</a:t>
                       </a:r>
                     </a:p>
                   </a:txBody>
@@ -10528,7 +10528,7 @@
                             <a:srgbClr val="0D1B2A"/>
                           </a:solidFill>
                         </a:rPr>
-                        <a:t>🤖</a:t>
+                        <a:t>02</a:t>
                       </a:r>
                     </a:p>
                   </a:txBody>
@@ -10596,7 +10596,7 @@
                             <a:srgbClr val="0D1B2A"/>
                           </a:solidFill>
                         </a:rPr>
-                        <a:t>📋</a:t>
+                        <a:t>03</a:t>
                       </a:r>
                     </a:p>
                   </a:txBody>
@@ -10664,7 +10664,7 @@
                             <a:srgbClr val="0D1B2A"/>
                           </a:solidFill>
                         </a:rPr>
-                        <a:t>👁</a:t>
+                        <a:t>04</a:t>
                       </a:r>
                     </a:p>
                   </a:txBody>
@@ -10686,7 +10686,7 @@
                             <a:srgbClr val="0D1B2A"/>
                           </a:solidFill>
                         </a:rPr>
-                        <a:t>24 / 7 Monitor</a:t>
+                        <a:t>24/7 Monitor</a:t>
                       </a:r>
                     </a:p>
                   </a:txBody>
@@ -10732,7 +10732,7 @@
                             <a:srgbClr val="0D1B2A"/>
                           </a:solidFill>
                         </a:rPr>
-                        <a:t>📡</a:t>
+                        <a:t>05</a:t>
                       </a:r>
                     </a:p>
                   </a:txBody>
@@ -10800,7 +10800,7 @@
                             <a:srgbClr val="0D1B2A"/>
                           </a:solidFill>
                         </a:rPr>
-                        <a:t>🚀</a:t>
+                        <a:t>06</a:t>
                       </a:r>
                     </a:p>
                   </a:txBody>
@@ -10844,7 +10844,7 @@
                             <a:srgbClr val="0D1B2A"/>
                           </a:solidFill>
                         </a:rPr>
-                        <a:t>Plain-language description → full YAML solution in &lt; 60 seconds</a:t>
+                        <a:t>Plain-language description to full YAML solution in under 60 seconds</a:t>
                       </a:r>
                     </a:p>
                   </a:txBody>
@@ -10868,7 +10868,7 @@
                             <a:srgbClr val="0D1B2A"/>
                           </a:solidFill>
                         </a:rPr>
-                        <a:t>📚</a:t>
+                        <a:t>07</a:t>
                       </a:r>
                     </a:p>
                   </a:txBody>
@@ -10936,7 +10936,7 @@
                             <a:srgbClr val="0D1B2A"/>
                           </a:solidFill>
                         </a:rPr>
-                        <a:t>💬</a:t>
+                        <a:t>08</a:t>
                       </a:r>
                     </a:p>
                   </a:txBody>
@@ -11004,7 +11004,7 @@
                             <a:srgbClr val="0D1B2A"/>
                           </a:solidFill>
                         </a:rPr>
-                        <a:t>🧪</a:t>
+                        <a:t>09</a:t>
                       </a:r>
                     </a:p>
                   </a:txBody>
@@ -11048,7 +11048,7 @@
                             <a:srgbClr val="0D1B2A"/>
                           </a:solidFill>
                         </a:rPr>
-                        <a:t>YAML test cases · 0–100 scoring · SQLite history · regression tracking</a:t>
+                        <a:t>YAML test cases, 0-100 scoring, SQLite history, regression tracking</a:t>
                       </a:r>
                     </a:p>
                   </a:txBody>
@@ -11072,7 +11072,7 @@
                             <a:srgbClr val="0D1B2A"/>
                           </a:solidFill>
                         </a:rPr>
-                        <a:t>🏢</a:t>
+                        <a:t>10</a:t>
                       </a:r>
                     </a:p>
                   </a:txBody>
@@ -11116,7 +11116,7 @@
                             <a:srgbClr val="0D1B2A"/>
                           </a:solidFill>
                         </a:rPr>
-                        <a:t>X-SAGE-Tenant header → per-team knowledge collection isolation</a:t>
+                        <a:t>X-SAGE-Tenant header — per-team knowledge collection isolation</a:t>
                       </a:r>
                     </a:p>
                   </a:txBody>
@@ -11140,7 +11140,7 @@
                             <a:srgbClr val="0D1B2A"/>
                           </a:solidFill>
                         </a:rPr>
-                        <a:t>⏱</a:t>
+                        <a:t>11</a:t>
                       </a:r>
                     </a:p>
                   </a:txBody>
@@ -11184,7 +11184,7 @@
                             <a:srgbClr val="0D1B2A"/>
                           </a:solidFill>
                         </a:rPr>
-                        <a:t>LangGraph (interrupt/resume) + Temporal — workflows survive server restart</a:t>
+                        <a:t>LangGraph interrupt/resume + Temporal — workflows survive server restart</a:t>
                       </a:r>
                     </a:p>
                   </a:txBody>
@@ -11208,7 +11208,7 @@
                             <a:srgbClr val="0D1B2A"/>
                           </a:solidFill>
                         </a:rPr>
-                        <a:t>📊</a:t>
+                        <a:t>12</a:t>
                       </a:r>
                     </a:p>
                   </a:txBody>
@@ -11276,7 +11276,7 @@
                             <a:srgbClr val="0D1B2A"/>
                           </a:solidFill>
                         </a:rPr>
-                        <a:t>🌐</a:t>
+                        <a:t>13</a:t>
                       </a:r>
                     </a:p>
                   </a:txBody>
@@ -11320,7 +11320,7 @@
                             <a:srgbClr val="0D1B2A"/>
                           </a:solidFill>
                         </a:rPr>
-                        <a:t>Dashboard · Analyst · Developer · Audit · Monitor — no CLI needed</a:t>
+                        <a:t>Dashboard, Analyst, Developer, Audit, Monitor — no CLI needed</a:t>
                       </a:r>
                     </a:p>
                   </a:txBody>
@@ -11578,7 +11578,7 @@
                   <a:srgbClr val="0D1B2A"/>
                 </a:solidFill>
               </a:rPr>
-              <a:t>✅  ISO 13485:2016  —  Quality Management System</a:t>
+              <a:t>ISO 13485:2016  —  Quality Management System</a:t>
             </a:r>
           </a:p>
         </p:txBody>
@@ -11612,7 +11612,7 @@
                   <a:srgbClr val="0D1B2A"/>
                 </a:solidFill>
               </a:rPr>
-              <a:t>✅  ISO 14971:2019  —  Risk Management — 7 risks identified &amp; controlled</a:t>
+              <a:t>ISO 14971:2019  —  Risk Management — 7 risks identified &amp; controlled</a:t>
             </a:r>
           </a:p>
         </p:txBody>
@@ -11646,7 +11646,7 @@
                   <a:srgbClr val="0D1B2A"/>
                 </a:solidFill>
               </a:rPr>
-              <a:t>✅  IEC 62304:2006  —  Medical Device Software Lifecycle</a:t>
+              <a:t>IEC 62304:2006  —  Medical Device Software Lifecycle</a:t>
             </a:r>
           </a:p>
         </p:txBody>
@@ -11680,7 +11680,7 @@
                   <a:srgbClr val="0D1B2A"/>
                 </a:solidFill>
               </a:rPr>
-              <a:t>✅  FDA 21 CFR Part 11  —  Electronic Records &amp; Signatures</a:t>
+              <a:t>FDA 21 CFR Part 11  —  Electronic Records &amp; Signatures</a:t>
             </a:r>
           </a:p>
         </p:txBody>
@@ -11714,7 +11714,7 @@
                   <a:srgbClr val="0D1B2A"/>
                 </a:solidFill>
               </a:rPr>
-              <a:t>✅  FDA Cybersecurity Guidance 2023  —  Threat modelling, SBOM, update policy</a:t>
+              <a:t>FDA Cybersecurity Guidance 2023  —  Threat modelling, SBOM, update policy</a:t>
             </a:r>
           </a:p>
         </p:txBody>
@@ -11782,7 +11782,7 @@
                   <a:srgbClr val="0D1B2A"/>
                 </a:solidFill>
               </a:rPr>
-              <a:t>  •  Immutable append-only audit log (no deletes, ever)</a:t>
+              <a:t>  Immutable append-only audit log (no deletes, ever)</a:t>
             </a:r>
           </a:p>
         </p:txBody>
@@ -11816,7 +11816,7 @@
                   <a:srgbClr val="0D1B2A"/>
                 </a:solidFill>
               </a:rPr>
-              <a:t>  •  UUID trace ID on every AI decision</a:t>
+              <a:t>  UUID trace ID on every AI decision</a:t>
             </a:r>
           </a:p>
         </p:txBody>
@@ -11850,7 +11850,7 @@
                   <a:srgbClr val="0D1B2A"/>
                 </a:solidFill>
               </a:rPr>
-              <a:t>  •  Human approval gate on every proposal — enforced in code</a:t>
+              <a:t>  Human approval gate on every proposal — enforced in code</a:t>
             </a:r>
           </a:p>
         </p:txBody>
@@ -11884,7 +11884,7 @@
                   <a:srgbClr val="0D1B2A"/>
                 </a:solidFill>
               </a:rPr>
-              <a:t>  •  Full DHF: SRS · RTM · V&amp;V Plan · SOUP Inventory</a:t>
+              <a:t>  Full DHF: SRS · RTM · V&amp;V Plan · SOUP Inventory</a:t>
             </a:r>
           </a:p>
         </p:txBody>
@@ -11918,7 +11918,7 @@
                   <a:srgbClr val="0D1B2A"/>
                 </a:solidFill>
               </a:rPr>
-              <a:t>  •  Air-gapped LLM option — no cloud dependency required</a:t>
+              <a:t>  Air-gapped LLM option — no cloud dependency required</a:t>
             </a:r>
           </a:p>
         </p:txBody>

</xml_diff>

<commit_message>
Update docs, fix dual-LLM endpoint, add permissions for venv/curl
- SAGE_ONE_PAGER.md: full Intelligence Layer v1 feature table, domain solutions table, 22-page dashboard table, Mermaid in stack
- API_REFERENCE.md: added HITL, SAGE SLM, Teacher-Student, SWE Agent, Visual Workflows, Task Queue, HIL, Compliance endpoints
- SAGE_Demo_Slides_v2.md: 17-slide demo script covering all v1 features
- SageAI_Tech_Pitch.pptx: added Composio + Hire Agent slides, updated developer experience slide
- SageAI_Business_Case.pptx: updated capabilities bullets, added 8th bullet
- SageAI_Investor_Pitch.pptx: added 6th technology moat, updated traction metrics
- api.py: fix /llm/dual-status endpoint (was passing str to DualLLMRunner instead of config dict)
- .claude/settings.json: add .venv/bin/python, .venv/bin/pip, .venv/bin/uvicorn, .venv/bin/pytest permissions

Co-Authored-By: Claude Sonnet 4.6 <noreply@anthropic.com>
</commit_message>
<xml_diff>
--- a/docs/SageAI_Business_Case.pptx
+++ b/docs/SageAI_Business_Case.pptx
@@ -6817,6 +6817,40 @@
                 </a:solidFill>
               </a:rPr>
               <a:t>SAGE[ai] — Confidential | March 2026</a:t>
+            </a:r>
+          </a:p>
+        </p:txBody>
+      </p:sp>
+      <p:sp>
+        <p:nvSpPr>
+          <p:cNvPr id="11" name="TextBox 10"/>
+          <p:cNvSpPr txBox="1"/>
+          <p:nvPr/>
+        </p:nvSpPr>
+        <p:spPr>
+          <a:xfrm>
+            <a:off x="502920" y="4666488"/>
+            <a:ext cx="11155680" cy="384048"/>
+          </a:xfrm>
+          <a:prstGeom prst="rect">
+            <a:avLst/>
+          </a:prstGeom>
+          <a:noFill/>
+        </p:spPr>
+        <p:txBody>
+          <a:bodyPr wrap="square">
+            <a:spAutoFit/>
+          </a:bodyPr>
+          <a:lstStyle/>
+          <a:p>
+            <a:pPr algn="l"/>
+            <a:r>
+              <a:rPr sz="1500" b="0" i="0">
+                <a:solidFill>
+                  <a:srgbClr val="0D1B2A"/>
+                </a:solidFill>
+              </a:rPr>
+              <a:t>Web dashboard for all stakeholders — hire new agent roles, connect tools, approve proposals</a:t>
             </a:r>
           </a:p>
         </p:txBody>

</xml_diff>

<commit_message>
feat: add browser E2E tests, update all docs for open-source, add product modules
- Add 79 Playwright browser E2E tests covering all 23 UI routes, 24 API
  endpoints, functional flows, error handling, and performance checks
- Update all 12 docs (API Reference, User Guide, Testing, Setup, etc.)
  to reflect current state: 136 endpoints, 27 pages, 17+ solutions
- Add open-source positioning to docs and regenerate all 3 PPTs with
  Apache 2.0 branding and community contribution framing
- Add product modules: backend, firmware, hardware, mobile, models, infra
- Add CI/CD workflows for backend, firmware, and mobile
- Add medtech DHF templates and security configs
- Add org.yaml for multi-solution organization

Co-Authored-By: Claude Opus 4.6 <noreply@anthropic.com>
</commit_message>
<xml_diff>
--- a/docs/SageAI_Business_Case.pptx
+++ b/docs/SageAI_Business_Case.pptx
@@ -3318,7 +3318,7 @@
                   <a:srgbClr val="647487"/>
                 </a:solidFill>
               </a:rPr>
-              <a:t>Business Case Presentation — March 2026</a:t>
+              <a:t>Open Source (Apache 2.0) — Business Case Presentation — March 2026</a:t>
             </a:r>
           </a:p>
         </p:txBody>
@@ -3352,7 +3352,7 @@
                   <a:srgbClr val="FFB700"/>
                 </a:solidFill>
               </a:rPr>
-              <a:t>CONFIDENTIAL — Internal Business Case</a:t>
+              <a:t>github.com/Sumanharapanahalli/sage</a:t>
             </a:r>
           </a:p>
         </p:txBody>
@@ -4035,7 +4035,7 @@
                   <a:srgbClr val="647487"/>
                 </a:solidFill>
               </a:rPr>
-              <a:t>SAGE[ai] — Confidential | March 2026</a:t>
+              <a:t>SAGE[ai] — Open Source (Apache 2.0) | github.com/Sumanharapanahalli/sage | March 2026</a:t>
             </a:r>
           </a:p>
         </p:txBody>
@@ -4997,7 +4997,7 @@
                   <a:srgbClr val="647487"/>
                 </a:solidFill>
               </a:rPr>
-              <a:t>SAGE[ai] — Confidential | March 2026</a:t>
+              <a:t>SAGE[ai] — Open Source (Apache 2.0) | github.com/Sumanharapanahalli/sage | March 2026</a:t>
             </a:r>
           </a:p>
         </p:txBody>
@@ -5628,7 +5628,7 @@
                   <a:srgbClr val="647487"/>
                 </a:solidFill>
               </a:rPr>
-              <a:t>SAGE[ai] — Confidential | March 2026</a:t>
+              <a:t>SAGE[ai] — Open Source (Apache 2.0) | github.com/Sumanharapanahalli/sage | March 2026</a:t>
             </a:r>
           </a:p>
         </p:txBody>
@@ -6286,7 +6286,7 @@
                 </a:solidFill>
                 <a:latin typeface="Calibri"/>
               </a:rPr>
-              <a:t>SAGE[ai] — Confidential | March 2026</a:t>
+              <a:t>SAGE[ai] — Open Source (Apache 2.0) | github.com/Sumanharapanahalli/sage | March 2026</a:t>
             </a:r>
           </a:p>
         </p:txBody>
@@ -6460,7 +6460,7 @@
                   <a:srgbClr val="00B4D8"/>
                 </a:solidFill>
               </a:rPr>
-              <a:t>Let's talk about your pilot.</a:t>
+              <a:t>Open source. Self-hosted. Start today at github.com/Sumanharapanahalli/sage</a:t>
             </a:r>
           </a:p>
         </p:txBody>
@@ -6946,7 +6946,7 @@
                   <a:srgbClr val="647487"/>
                 </a:solidFill>
               </a:rPr>
-              <a:t>SAGE[ai] — Confidential | March 2026</a:t>
+              <a:t>SAGE[ai] — Open Source (Apache 2.0) | github.com/Sumanharapanahalli/sage | March 2026</a:t>
             </a:r>
           </a:p>
         </p:txBody>
@@ -7321,7 +7321,7 @@
                   <a:srgbClr val="0D1B2A"/>
                 </a:solidFill>
               </a:rPr>
-              <a:t>100+ tool integrations via Composio — GitHub, Jira, Salesforce, Slack and more</a:t>
+              <a:t>Web dashboard for all stakeholders — zero CLI required</a:t>
             </a:r>
           </a:p>
         </p:txBody>
@@ -7398,75 +7398,7 @@
                   <a:srgbClr val="647487"/>
                 </a:solidFill>
               </a:rPr>
-              <a:t>SAGE[ai] — Confidential | March 2026</a:t>
-            </a:r>
-          </a:p>
-        </p:txBody>
-      </p:sp>
-      <p:sp>
-        <p:nvSpPr>
-          <p:cNvPr id="11" name="TextBox 10"/>
-          <p:cNvSpPr txBox="1"/>
-          <p:nvPr/>
-        </p:nvSpPr>
-        <p:spPr>
-          <a:xfrm>
-            <a:off x="502920" y="4666488"/>
-            <a:ext cx="11155680" cy="384048"/>
-          </a:xfrm>
-          <a:prstGeom prst="rect">
-            <a:avLst/>
-          </a:prstGeom>
-          <a:noFill/>
-        </p:spPr>
-        <p:txBody>
-          <a:bodyPr wrap="square">
-            <a:spAutoFit/>
-          </a:bodyPr>
-          <a:lstStyle/>
-          <a:p>
-            <a:pPr algn="l"/>
-            <a:r>
-              <a:rPr sz="1500" b="0" i="0">
-                <a:solidFill>
-                  <a:srgbClr val="0D1B2A"/>
-                </a:solidFill>
-              </a:rPr>
-              <a:t>Web dashboard for all stakeholders — hire new agent roles, connect tools, approve proposals</a:t>
-            </a:r>
-          </a:p>
-        </p:txBody>
-      </p:sp>
-      <p:sp>
-        <p:nvSpPr>
-          <p:cNvPr id="11" name="TextBox 10"/>
-          <p:cNvSpPr txBox="1"/>
-          <p:nvPr/>
-        </p:nvSpPr>
-        <p:spPr>
-          <a:xfrm>
-            <a:off x="502920" y="4666488"/>
-            <a:ext cx="11155680" cy="384048"/>
-          </a:xfrm>
-          <a:prstGeom prst="rect">
-            <a:avLst/>
-          </a:prstGeom>
-          <a:noFill/>
-        </p:spPr>
-        <p:txBody>
-          <a:bodyPr wrap="square">
-            <a:spAutoFit/>
-          </a:bodyPr>
-          <a:lstStyle/>
-          <a:p>
-            <a:pPr algn="l"/>
-            <a:r>
-              <a:rPr sz="1500" b="0" i="0">
-                <a:solidFill>
-                  <a:srgbClr val="0D1B2A"/>
-                </a:solidFill>
-              </a:rPr>
-              <a:t>Web dashboard for all stakeholders — hire new agent roles, connect tools, approve proposals</a:t>
+              <a:t>SAGE[ai] — Open Source (Apache 2.0) | github.com/Sumanharapanahalli/sage | March 2026</a:t>
             </a:r>
           </a:p>
         </p:txBody>
@@ -8353,7 +8285,7 @@
                   <a:srgbClr val="647487"/>
                 </a:solidFill>
               </a:rPr>
-              <a:t>SAGE[ai] — Confidential | March 2026</a:t>
+              <a:t>SAGE[ai] — Open Source (Apache 2.0) | github.com/Sumanharapanahalli/sage | March 2026</a:t>
             </a:r>
           </a:p>
         </p:txBody>
@@ -8915,7 +8847,7 @@
                   <a:srgbClr val="647487"/>
                 </a:solidFill>
               </a:rPr>
-              <a:t>SAGE[ai] — Confidential | March 2026</a:t>
+              <a:t>SAGE[ai] — Open Source (Apache 2.0) | github.com/Sumanharapanahalli/sage | March 2026</a:t>
             </a:r>
           </a:p>
         </p:txBody>
@@ -9731,7 +9663,7 @@
                   <a:srgbClr val="647487"/>
                 </a:solidFill>
               </a:rPr>
-              <a:t>SAGE[ai] — Confidential | March 2026</a:t>
+              <a:t>SAGE[ai] — Open Source (Apache 2.0) | github.com/Sumanharapanahalli/sage | March 2026</a:t>
             </a:r>
           </a:p>
         </p:txBody>
@@ -10864,7 +10796,7 @@
                   <a:srgbClr val="647487"/>
                 </a:solidFill>
               </a:rPr>
-              <a:t>SAGE[ai] — Confidential | March 2026</a:t>
+              <a:t>SAGE[ai] — Open Source (Apache 2.0) | github.com/Sumanharapanahalli/sage | March 2026</a:t>
             </a:r>
           </a:p>
         </p:txBody>
@@ -11001,7 +10933,7 @@
                   <a:srgbClr val="00B4D8"/>
                 </a:solidFill>
               </a:rPr>
-              <a:t>Production-ready capabilities — agents, tools, approvals, and 100+ integrations — available now</a:t>
+              <a:t>136 API endpoints across 12 integration phases — all open source (Apache 2.0)</a:t>
             </a:r>
           </a:p>
         </p:txBody>
@@ -12057,7 +11989,7 @@
                   <a:srgbClr val="647487"/>
                 </a:solidFill>
               </a:rPr>
-              <a:t>SAGE[ai] — Confidential | March 2026</a:t>
+              <a:t>SAGE[ai] — Open Source (Apache 2.0) | github.com/Sumanharapanahalli/sage | March 2026</a:t>
             </a:r>
           </a:p>
         </p:txBody>
@@ -12645,7 +12577,7 @@
                   <a:srgbClr val="647487"/>
                 </a:solidFill>
               </a:rPr>
-              <a:t>SAGE[ai] — Confidential | March 2026</a:t>
+              <a:t>SAGE[ai] — Open Source (Apache 2.0) | github.com/Sumanharapanahalli/sage | March 2026</a:t>
             </a:r>
           </a:p>
         </p:txBody>

</xml_diff>